<commit_message>
Final push: Ensure presentation synchronization
</commit_message>
<xml_diff>
--- a/Loan_Approval_Prediction_Presentation.pptx
+++ b/Loan_Approval_Prediction_Presentation.pptx
@@ -5,20 +5,20 @@
     <p:sldMasterId id="2147483648" r:id="rId1"/>
   </p:sldMasterIdLst>
   <p:sldIdLst>
-    <p:sldId id="256" r:id="rId7"/>
-    <p:sldId id="257" r:id="rId8"/>
-    <p:sldId id="258" r:id="rId9"/>
-    <p:sldId id="259" r:id="rId10"/>
-    <p:sldId id="260" r:id="rId11"/>
-    <p:sldId id="261" r:id="rId12"/>
-    <p:sldId id="262" r:id="rId13"/>
-    <p:sldId id="263" r:id="rId14"/>
-    <p:sldId id="264" r:id="rId15"/>
-    <p:sldId id="265" r:id="rId16"/>
-    <p:sldId id="266" r:id="rId17"/>
-    <p:sldId id="267" r:id="rId18"/>
+    <p:sldId id="256" r:id="rId2"/>
+    <p:sldId id="257" r:id="rId3"/>
+    <p:sldId id="258" r:id="rId4"/>
+    <p:sldId id="259" r:id="rId5"/>
+    <p:sldId id="260" r:id="rId6"/>
+    <p:sldId id="261" r:id="rId7"/>
+    <p:sldId id="262" r:id="rId8"/>
+    <p:sldId id="263" r:id="rId9"/>
+    <p:sldId id="264" r:id="rId10"/>
+    <p:sldId id="265" r:id="rId11"/>
+    <p:sldId id="266" r:id="rId12"/>
+    <p:sldId id="267" r:id="rId13"/>
   </p:sldIdLst>
-  <p:sldSz cx="12191695" cy="6858000" type="screen4x3"/>
+  <p:sldSz cx="12192000" cy="6858000"/>
   <p:notesSz cx="6858000" cy="9144000"/>
   <p:defaultTextStyle>
     <a:defPPr>
@@ -115,7 +115,52 @@
       </a:defRPr>
     </a:lvl9pPr>
   </p:defaultTextStyle>
+  <p:extLst>
+    <p:ext uri="{EFAFB233-063F-42B5-8137-9DF3F51BA10A}">
+      <p15:sldGuideLst xmlns:p15="http://schemas.microsoft.com/office/powerpoint/2012/main">
+        <p15:guide id="1" orient="horz" pos="2160">
+          <p15:clr>
+            <a:srgbClr val="A4A3A4"/>
+          </p15:clr>
+        </p15:guide>
+        <p15:guide id="2" pos="2880">
+          <p15:clr>
+            <a:srgbClr val="A4A3A4"/>
+          </p15:clr>
+        </p15:guide>
+      </p15:sldGuideLst>
+    </p:ext>
+  </p:extLst>
 </p:presentation>
+</file>
+
+<file path=ppt/changesInfos/changesInfo1.xml><?xml version="1.0" encoding="utf-8"?>
+<pc:chgInfo xmlns:a="http://schemas.openxmlformats.org/drawingml/2006/main" xmlns:r="http://schemas.openxmlformats.org/officeDocument/2006/relationships" xmlns:ac="http://schemas.microsoft.com/office/drawing/2013/main/command" xmlns:pc="http://schemas.microsoft.com/office/powerpoint/2013/main/command">
+  <pc:docChgLst>
+    <pc:chgData name="Md Aamir" userId="8dcdb3e5c81ab522" providerId="LiveId" clId="{6DFFCF00-7326-434A-986D-5331E0648DBB}"/>
+    <pc:docChg chg="custSel modSld">
+      <pc:chgData name="Md Aamir" userId="8dcdb3e5c81ab522" providerId="LiveId" clId="{6DFFCF00-7326-434A-986D-5331E0648DBB}" dt="2026-07-20T13:14:42.551" v="1" actId="21"/>
+      <pc:docMkLst>
+        <pc:docMk/>
+      </pc:docMkLst>
+      <pc:sldChg chg="addSp delSp mod">
+        <pc:chgData name="Md Aamir" userId="8dcdb3e5c81ab522" providerId="LiveId" clId="{6DFFCF00-7326-434A-986D-5331E0648DBB}" dt="2026-07-20T13:14:42.551" v="1" actId="21"/>
+        <pc:sldMkLst>
+          <pc:docMk/>
+          <pc:sldMk cId="0" sldId="265"/>
+        </pc:sldMkLst>
+        <pc:graphicFrameChg chg="add del">
+          <ac:chgData name="Md Aamir" userId="8dcdb3e5c81ab522" providerId="LiveId" clId="{6DFFCF00-7326-434A-986D-5331E0648DBB}" dt="2026-07-20T13:14:42.551" v="1" actId="21"/>
+          <ac:graphicFrameMkLst>
+            <pc:docMk/>
+            <pc:sldMk cId="0" sldId="265"/>
+            <ac:graphicFrameMk id="7" creationId="{91543B39-5D8C-E8B6-CDED-FA253C03DD73}"/>
+          </ac:graphicFrameMkLst>
+        </pc:graphicFrameChg>
+      </pc:sldChg>
+    </pc:docChg>
+  </pc:docChgLst>
+</pc:chgInfo>
 </file>
 
 <file path=ppt/slideLayouts/slideLayout1.xml><?xml version="1.0" encoding="utf-8"?>
@@ -156,10 +201,9 @@
           <a:lstStyle/>
           <a:p>
             <a:r>
-              <a:rPr lang="en-US" smtClean="0"/>
+              <a:rPr lang="en-US"/>
               <a:t>Click to edit Master title style</a:t>
             </a:r>
-            <a:endParaRPr lang="en-US"/>
           </a:p>
         </p:txBody>
       </p:sp>
@@ -275,10 +319,9 @@
           </a:lstStyle>
           <a:p>
             <a:r>
-              <a:rPr lang="en-US" smtClean="0"/>
+              <a:rPr lang="en-US"/>
               <a:t>Click to edit Master subtitle style</a:t>
             </a:r>
-            <a:endParaRPr lang="en-US"/>
           </a:p>
         </p:txBody>
       </p:sp>
@@ -299,7 +342,7 @@
           <a:p>
             <a:fld id="{5BCAD085-E8A6-8845-BD4E-CB4CCA059FC4}" type="datetimeFigureOut">
               <a:rPr lang="en-US" smtClean="0"/>
-              <a:t>1/27/13</a:t>
+              <a:t>7/20/2026</a:t>
             </a:fld>
             <a:endParaRPr lang="en-US"/>
           </a:p>
@@ -393,10 +436,9 @@
           <a:lstStyle/>
           <a:p>
             <a:r>
-              <a:rPr lang="en-US" smtClean="0"/>
+              <a:rPr lang="en-US"/>
               <a:t>Click to edit Master title style</a:t>
             </a:r>
-            <a:endParaRPr lang="en-US"/>
           </a:p>
         </p:txBody>
       </p:sp>
@@ -417,38 +459,37 @@
           <a:p>
             <a:pPr lvl="0"/>
             <a:r>
-              <a:rPr lang="en-US" smtClean="0"/>
+              <a:rPr lang="en-US"/>
               <a:t>Click to edit Master text styles</a:t>
             </a:r>
           </a:p>
           <a:p>
             <a:pPr lvl="1"/>
             <a:r>
-              <a:rPr lang="en-US" smtClean="0"/>
+              <a:rPr lang="en-US"/>
               <a:t>Second level</a:t>
             </a:r>
           </a:p>
           <a:p>
             <a:pPr lvl="2"/>
             <a:r>
-              <a:rPr lang="en-US" smtClean="0"/>
+              <a:rPr lang="en-US"/>
               <a:t>Third level</a:t>
             </a:r>
           </a:p>
           <a:p>
             <a:pPr lvl="3"/>
             <a:r>
-              <a:rPr lang="en-US" smtClean="0"/>
+              <a:rPr lang="en-US"/>
               <a:t>Fourth level</a:t>
             </a:r>
           </a:p>
           <a:p>
             <a:pPr lvl="4"/>
             <a:r>
-              <a:rPr lang="en-US" smtClean="0"/>
+              <a:rPr lang="en-US"/>
               <a:t>Fifth level</a:t>
             </a:r>
-            <a:endParaRPr lang="en-US"/>
           </a:p>
         </p:txBody>
       </p:sp>
@@ -469,7 +510,7 @@
           <a:p>
             <a:fld id="{5BCAD085-E8A6-8845-BD4E-CB4CCA059FC4}" type="datetimeFigureOut">
               <a:rPr lang="en-US" smtClean="0"/>
-              <a:t>1/27/13</a:t>
+              <a:t>7/20/2026</a:t>
             </a:fld>
             <a:endParaRPr lang="en-US"/>
           </a:p>
@@ -568,10 +609,9 @@
           <a:lstStyle/>
           <a:p>
             <a:r>
-              <a:rPr lang="en-US" smtClean="0"/>
+              <a:rPr lang="en-US"/>
               <a:t>Click to edit Master title style</a:t>
             </a:r>
-            <a:endParaRPr lang="en-US"/>
           </a:p>
         </p:txBody>
       </p:sp>
@@ -597,38 +637,37 @@
           <a:p>
             <a:pPr lvl="0"/>
             <a:r>
-              <a:rPr lang="en-US" smtClean="0"/>
+              <a:rPr lang="en-US"/>
               <a:t>Click to edit Master text styles</a:t>
             </a:r>
           </a:p>
           <a:p>
             <a:pPr lvl="1"/>
             <a:r>
-              <a:rPr lang="en-US" smtClean="0"/>
+              <a:rPr lang="en-US"/>
               <a:t>Second level</a:t>
             </a:r>
           </a:p>
           <a:p>
             <a:pPr lvl="2"/>
             <a:r>
-              <a:rPr lang="en-US" smtClean="0"/>
+              <a:rPr lang="en-US"/>
               <a:t>Third level</a:t>
             </a:r>
           </a:p>
           <a:p>
             <a:pPr lvl="3"/>
             <a:r>
-              <a:rPr lang="en-US" smtClean="0"/>
+              <a:rPr lang="en-US"/>
               <a:t>Fourth level</a:t>
             </a:r>
           </a:p>
           <a:p>
             <a:pPr lvl="4"/>
             <a:r>
-              <a:rPr lang="en-US" smtClean="0"/>
+              <a:rPr lang="en-US"/>
               <a:t>Fifth level</a:t>
             </a:r>
-            <a:endParaRPr lang="en-US"/>
           </a:p>
         </p:txBody>
       </p:sp>
@@ -649,7 +688,7 @@
           <a:p>
             <a:fld id="{5BCAD085-E8A6-8845-BD4E-CB4CCA059FC4}" type="datetimeFigureOut">
               <a:rPr lang="en-US" smtClean="0"/>
-              <a:t>1/27/13</a:t>
+              <a:t>7/20/2026</a:t>
             </a:fld>
             <a:endParaRPr lang="en-US"/>
           </a:p>
@@ -743,10 +782,9 @@
           <a:lstStyle/>
           <a:p>
             <a:r>
-              <a:rPr lang="en-US" smtClean="0"/>
+              <a:rPr lang="en-US"/>
               <a:t>Click to edit Master title style</a:t>
             </a:r>
-            <a:endParaRPr lang="en-US"/>
           </a:p>
         </p:txBody>
       </p:sp>
@@ -767,38 +805,37 @@
           <a:p>
             <a:pPr lvl="0"/>
             <a:r>
-              <a:rPr lang="en-US" smtClean="0"/>
+              <a:rPr lang="en-US"/>
               <a:t>Click to edit Master text styles</a:t>
             </a:r>
           </a:p>
           <a:p>
             <a:pPr lvl="1"/>
             <a:r>
-              <a:rPr lang="en-US" smtClean="0"/>
+              <a:rPr lang="en-US"/>
               <a:t>Second level</a:t>
             </a:r>
           </a:p>
           <a:p>
             <a:pPr lvl="2"/>
             <a:r>
-              <a:rPr lang="en-US" smtClean="0"/>
+              <a:rPr lang="en-US"/>
               <a:t>Third level</a:t>
             </a:r>
           </a:p>
           <a:p>
             <a:pPr lvl="3"/>
             <a:r>
-              <a:rPr lang="en-US" smtClean="0"/>
+              <a:rPr lang="en-US"/>
               <a:t>Fourth level</a:t>
             </a:r>
           </a:p>
           <a:p>
             <a:pPr lvl="4"/>
             <a:r>
-              <a:rPr lang="en-US" smtClean="0"/>
+              <a:rPr lang="en-US"/>
               <a:t>Fifth level</a:t>
             </a:r>
-            <a:endParaRPr lang="en-US"/>
           </a:p>
         </p:txBody>
       </p:sp>
@@ -819,7 +856,7 @@
           <a:p>
             <a:fld id="{5BCAD085-E8A6-8845-BD4E-CB4CCA059FC4}" type="datetimeFigureOut">
               <a:rPr lang="en-US" smtClean="0"/>
-              <a:t>1/27/13</a:t>
+              <a:t>7/20/2026</a:t>
             </a:fld>
             <a:endParaRPr lang="en-US"/>
           </a:p>
@@ -922,10 +959,9 @@
           </a:lstStyle>
           <a:p>
             <a:r>
-              <a:rPr lang="en-US" smtClean="0"/>
+              <a:rPr lang="en-US"/>
               <a:t>Click to edit Master title style</a:t>
             </a:r>
-            <a:endParaRPr lang="en-US"/>
           </a:p>
         </p:txBody>
       </p:sp>
@@ -1042,7 +1078,7 @@
           <a:p>
             <a:pPr lvl="0"/>
             <a:r>
-              <a:rPr lang="en-US" smtClean="0"/>
+              <a:rPr lang="en-US"/>
               <a:t>Click to edit Master text styles</a:t>
             </a:r>
           </a:p>
@@ -1065,7 +1101,7 @@
           <a:p>
             <a:fld id="{5BCAD085-E8A6-8845-BD4E-CB4CCA059FC4}" type="datetimeFigureOut">
               <a:rPr lang="en-US" smtClean="0"/>
-              <a:t>1/27/13</a:t>
+              <a:t>7/20/2026</a:t>
             </a:fld>
             <a:endParaRPr lang="en-US"/>
           </a:p>
@@ -1159,10 +1195,9 @@
           <a:lstStyle/>
           <a:p>
             <a:r>
-              <a:rPr lang="en-US" smtClean="0"/>
+              <a:rPr lang="en-US"/>
               <a:t>Click to edit Master title style</a:t>
             </a:r>
-            <a:endParaRPr lang="en-US"/>
           </a:p>
         </p:txBody>
       </p:sp>
@@ -1216,38 +1251,37 @@
           <a:p>
             <a:pPr lvl="0"/>
             <a:r>
-              <a:rPr lang="en-US" smtClean="0"/>
+              <a:rPr lang="en-US"/>
               <a:t>Click to edit Master text styles</a:t>
             </a:r>
           </a:p>
           <a:p>
             <a:pPr lvl="1"/>
             <a:r>
-              <a:rPr lang="en-US" smtClean="0"/>
+              <a:rPr lang="en-US"/>
               <a:t>Second level</a:t>
             </a:r>
           </a:p>
           <a:p>
             <a:pPr lvl="2"/>
             <a:r>
-              <a:rPr lang="en-US" smtClean="0"/>
+              <a:rPr lang="en-US"/>
               <a:t>Third level</a:t>
             </a:r>
           </a:p>
           <a:p>
             <a:pPr lvl="3"/>
             <a:r>
-              <a:rPr lang="en-US" smtClean="0"/>
+              <a:rPr lang="en-US"/>
               <a:t>Fourth level</a:t>
             </a:r>
           </a:p>
           <a:p>
             <a:pPr lvl="4"/>
             <a:r>
-              <a:rPr lang="en-US" smtClean="0"/>
+              <a:rPr lang="en-US"/>
               <a:t>Fifth level</a:t>
             </a:r>
-            <a:endParaRPr lang="en-US"/>
           </a:p>
         </p:txBody>
       </p:sp>
@@ -1301,38 +1335,37 @@
           <a:p>
             <a:pPr lvl="0"/>
             <a:r>
-              <a:rPr lang="en-US" smtClean="0"/>
+              <a:rPr lang="en-US"/>
               <a:t>Click to edit Master text styles</a:t>
             </a:r>
           </a:p>
           <a:p>
             <a:pPr lvl="1"/>
             <a:r>
-              <a:rPr lang="en-US" smtClean="0"/>
+              <a:rPr lang="en-US"/>
               <a:t>Second level</a:t>
             </a:r>
           </a:p>
           <a:p>
             <a:pPr lvl="2"/>
             <a:r>
-              <a:rPr lang="en-US" smtClean="0"/>
+              <a:rPr lang="en-US"/>
               <a:t>Third level</a:t>
             </a:r>
           </a:p>
           <a:p>
             <a:pPr lvl="3"/>
             <a:r>
-              <a:rPr lang="en-US" smtClean="0"/>
+              <a:rPr lang="en-US"/>
               <a:t>Fourth level</a:t>
             </a:r>
           </a:p>
           <a:p>
             <a:pPr lvl="4"/>
             <a:r>
-              <a:rPr lang="en-US" smtClean="0"/>
+              <a:rPr lang="en-US"/>
               <a:t>Fifth level</a:t>
             </a:r>
-            <a:endParaRPr lang="en-US"/>
           </a:p>
         </p:txBody>
       </p:sp>
@@ -1353,7 +1386,7 @@
           <a:p>
             <a:fld id="{5BCAD085-E8A6-8845-BD4E-CB4CCA059FC4}" type="datetimeFigureOut">
               <a:rPr lang="en-US" smtClean="0"/>
-              <a:t>1/27/13</a:t>
+              <a:t>7/20/2026</a:t>
             </a:fld>
             <a:endParaRPr lang="en-US"/>
           </a:p>
@@ -1451,10 +1484,9 @@
           </a:lstStyle>
           <a:p>
             <a:r>
-              <a:rPr lang="en-US" smtClean="0"/>
+              <a:rPr lang="en-US"/>
               <a:t>Click to edit Master title style</a:t>
             </a:r>
-            <a:endParaRPr lang="en-US"/>
           </a:p>
         </p:txBody>
       </p:sp>
@@ -1517,7 +1549,7 @@
           <a:p>
             <a:pPr lvl="0"/>
             <a:r>
-              <a:rPr lang="en-US" smtClean="0"/>
+              <a:rPr lang="en-US"/>
               <a:t>Click to edit Master text styles</a:t>
             </a:r>
           </a:p>
@@ -1573,38 +1605,37 @@
           <a:p>
             <a:pPr lvl="0"/>
             <a:r>
-              <a:rPr lang="en-US" smtClean="0"/>
+              <a:rPr lang="en-US"/>
               <a:t>Click to edit Master text styles</a:t>
             </a:r>
           </a:p>
           <a:p>
             <a:pPr lvl="1"/>
             <a:r>
-              <a:rPr lang="en-US" smtClean="0"/>
+              <a:rPr lang="en-US"/>
               <a:t>Second level</a:t>
             </a:r>
           </a:p>
           <a:p>
             <a:pPr lvl="2"/>
             <a:r>
-              <a:rPr lang="en-US" smtClean="0"/>
+              <a:rPr lang="en-US"/>
               <a:t>Third level</a:t>
             </a:r>
           </a:p>
           <a:p>
             <a:pPr lvl="3"/>
             <a:r>
-              <a:rPr lang="en-US" smtClean="0"/>
+              <a:rPr lang="en-US"/>
               <a:t>Fourth level</a:t>
             </a:r>
           </a:p>
           <a:p>
             <a:pPr lvl="4"/>
             <a:r>
-              <a:rPr lang="en-US" smtClean="0"/>
+              <a:rPr lang="en-US"/>
               <a:t>Fifth level</a:t>
             </a:r>
-            <a:endParaRPr lang="en-US"/>
           </a:p>
         </p:txBody>
       </p:sp>
@@ -1667,7 +1698,7 @@
           <a:p>
             <a:pPr lvl="0"/>
             <a:r>
-              <a:rPr lang="en-US" smtClean="0"/>
+              <a:rPr lang="en-US"/>
               <a:t>Click to edit Master text styles</a:t>
             </a:r>
           </a:p>
@@ -1723,38 +1754,37 @@
           <a:p>
             <a:pPr lvl="0"/>
             <a:r>
-              <a:rPr lang="en-US" smtClean="0"/>
+              <a:rPr lang="en-US"/>
               <a:t>Click to edit Master text styles</a:t>
             </a:r>
           </a:p>
           <a:p>
             <a:pPr lvl="1"/>
             <a:r>
-              <a:rPr lang="en-US" smtClean="0"/>
+              <a:rPr lang="en-US"/>
               <a:t>Second level</a:t>
             </a:r>
           </a:p>
           <a:p>
             <a:pPr lvl="2"/>
             <a:r>
-              <a:rPr lang="en-US" smtClean="0"/>
+              <a:rPr lang="en-US"/>
               <a:t>Third level</a:t>
             </a:r>
           </a:p>
           <a:p>
             <a:pPr lvl="3"/>
             <a:r>
-              <a:rPr lang="en-US" smtClean="0"/>
+              <a:rPr lang="en-US"/>
               <a:t>Fourth level</a:t>
             </a:r>
           </a:p>
           <a:p>
             <a:pPr lvl="4"/>
             <a:r>
-              <a:rPr lang="en-US" smtClean="0"/>
+              <a:rPr lang="en-US"/>
               <a:t>Fifth level</a:t>
             </a:r>
-            <a:endParaRPr lang="en-US"/>
           </a:p>
         </p:txBody>
       </p:sp>
@@ -1775,7 +1805,7 @@
           <a:p>
             <a:fld id="{5BCAD085-E8A6-8845-BD4E-CB4CCA059FC4}" type="datetimeFigureOut">
               <a:rPr lang="en-US" smtClean="0"/>
-              <a:t>1/27/13</a:t>
+              <a:t>7/20/2026</a:t>
             </a:fld>
             <a:endParaRPr lang="en-US"/>
           </a:p>
@@ -1869,10 +1899,9 @@
           <a:lstStyle/>
           <a:p>
             <a:r>
-              <a:rPr lang="en-US" smtClean="0"/>
+              <a:rPr lang="en-US"/>
               <a:t>Click to edit Master title style</a:t>
             </a:r>
-            <a:endParaRPr lang="en-US"/>
           </a:p>
         </p:txBody>
       </p:sp>
@@ -1893,7 +1922,7 @@
           <a:p>
             <a:fld id="{5BCAD085-E8A6-8845-BD4E-CB4CCA059FC4}" type="datetimeFigureOut">
               <a:rPr lang="en-US" smtClean="0"/>
-              <a:t>1/27/13</a:t>
+              <a:t>7/20/2026</a:t>
             </a:fld>
             <a:endParaRPr lang="en-US"/>
           </a:p>
@@ -1988,7 +2017,7 @@
           <a:p>
             <a:fld id="{5BCAD085-E8A6-8845-BD4E-CB4CCA059FC4}" type="datetimeFigureOut">
               <a:rPr lang="en-US" smtClean="0"/>
-              <a:t>1/27/13</a:t>
+              <a:t>7/20/2026</a:t>
             </a:fld>
             <a:endParaRPr lang="en-US"/>
           </a:p>
@@ -2091,10 +2120,9 @@
           </a:lstStyle>
           <a:p>
             <a:r>
-              <a:rPr lang="en-US" smtClean="0"/>
+              <a:rPr lang="en-US"/>
               <a:t>Click to edit Master title style</a:t>
             </a:r>
-            <a:endParaRPr lang="en-US"/>
           </a:p>
         </p:txBody>
       </p:sp>
@@ -2148,38 +2176,37 @@
           <a:p>
             <a:pPr lvl="0"/>
             <a:r>
-              <a:rPr lang="en-US" smtClean="0"/>
+              <a:rPr lang="en-US"/>
               <a:t>Click to edit Master text styles</a:t>
             </a:r>
           </a:p>
           <a:p>
             <a:pPr lvl="1"/>
             <a:r>
-              <a:rPr lang="en-US" smtClean="0"/>
+              <a:rPr lang="en-US"/>
               <a:t>Second level</a:t>
             </a:r>
           </a:p>
           <a:p>
             <a:pPr lvl="2"/>
             <a:r>
-              <a:rPr lang="en-US" smtClean="0"/>
+              <a:rPr lang="en-US"/>
               <a:t>Third level</a:t>
             </a:r>
           </a:p>
           <a:p>
             <a:pPr lvl="3"/>
             <a:r>
-              <a:rPr lang="en-US" smtClean="0"/>
+              <a:rPr lang="en-US"/>
               <a:t>Fourth level</a:t>
             </a:r>
           </a:p>
           <a:p>
             <a:pPr lvl="4"/>
             <a:r>
-              <a:rPr lang="en-US" smtClean="0"/>
+              <a:rPr lang="en-US"/>
               <a:t>Fifth level</a:t>
             </a:r>
-            <a:endParaRPr lang="en-US"/>
           </a:p>
         </p:txBody>
       </p:sp>
@@ -2242,7 +2269,7 @@
           <a:p>
             <a:pPr lvl="0"/>
             <a:r>
-              <a:rPr lang="en-US" smtClean="0"/>
+              <a:rPr lang="en-US"/>
               <a:t>Click to edit Master text styles</a:t>
             </a:r>
           </a:p>
@@ -2265,7 +2292,7 @@
           <a:p>
             <a:fld id="{5BCAD085-E8A6-8845-BD4E-CB4CCA059FC4}" type="datetimeFigureOut">
               <a:rPr lang="en-US" smtClean="0"/>
-              <a:t>1/27/13</a:t>
+              <a:t>7/20/2026</a:t>
             </a:fld>
             <a:endParaRPr lang="en-US"/>
           </a:p>
@@ -2368,10 +2395,9 @@
           </a:lstStyle>
           <a:p>
             <a:r>
-              <a:rPr lang="en-US" smtClean="0"/>
+              <a:rPr lang="en-US"/>
               <a:t>Click to edit Master title style</a:t>
             </a:r>
-            <a:endParaRPr lang="en-US"/>
           </a:p>
         </p:txBody>
       </p:sp>
@@ -2495,7 +2521,7 @@
           <a:p>
             <a:pPr lvl="0"/>
             <a:r>
-              <a:rPr lang="en-US" smtClean="0"/>
+              <a:rPr lang="en-US"/>
               <a:t>Click to edit Master text styles</a:t>
             </a:r>
           </a:p>
@@ -2518,7 +2544,7 @@
           <a:p>
             <a:fld id="{5BCAD085-E8A6-8845-BD4E-CB4CCA059FC4}" type="datetimeFigureOut">
               <a:rPr lang="en-US" smtClean="0"/>
-              <a:t>1/27/13</a:t>
+              <a:t>7/20/2026</a:t>
             </a:fld>
             <a:endParaRPr lang="en-US"/>
           </a:p>
@@ -2627,10 +2653,9 @@
           <a:lstStyle/>
           <a:p>
             <a:r>
-              <a:rPr lang="en-US" smtClean="0"/>
+              <a:rPr lang="en-US"/>
               <a:t>Click to edit Master title style</a:t>
             </a:r>
-            <a:endParaRPr lang="en-US"/>
           </a:p>
         </p:txBody>
       </p:sp>
@@ -2661,38 +2686,37 @@
           <a:p>
             <a:pPr lvl="0"/>
             <a:r>
-              <a:rPr lang="en-US" smtClean="0"/>
+              <a:rPr lang="en-US"/>
               <a:t>Click to edit Master text styles</a:t>
             </a:r>
           </a:p>
           <a:p>
             <a:pPr lvl="1"/>
             <a:r>
-              <a:rPr lang="en-US" smtClean="0"/>
+              <a:rPr lang="en-US"/>
               <a:t>Second level</a:t>
             </a:r>
           </a:p>
           <a:p>
             <a:pPr lvl="2"/>
             <a:r>
-              <a:rPr lang="en-US" smtClean="0"/>
+              <a:rPr lang="en-US"/>
               <a:t>Third level</a:t>
             </a:r>
           </a:p>
           <a:p>
             <a:pPr lvl="3"/>
             <a:r>
-              <a:rPr lang="en-US" smtClean="0"/>
+              <a:rPr lang="en-US"/>
               <a:t>Fourth level</a:t>
             </a:r>
           </a:p>
           <a:p>
             <a:pPr lvl="4"/>
             <a:r>
-              <a:rPr lang="en-US" smtClean="0"/>
+              <a:rPr lang="en-US"/>
               <a:t>Fifth level</a:t>
             </a:r>
-            <a:endParaRPr lang="en-US"/>
           </a:p>
         </p:txBody>
       </p:sp>
@@ -2731,7 +2755,7 @@
           <a:p>
             <a:fld id="{5BCAD085-E8A6-8845-BD4E-CB4CCA059FC4}" type="datetimeFigureOut">
               <a:rPr lang="en-US" smtClean="0"/>
-              <a:t>1/27/13</a:t>
+              <a:t>7/20/2026</a:t>
             </a:fld>
             <a:endParaRPr lang="en-US"/>
           </a:p>
@@ -3090,7 +3114,7 @@
 </file>
 
 <file path=ppt/slides/slide1.xml><?xml version="1.0" encoding="utf-8"?>
-<p:sld xmlns:a="http://schemas.openxmlformats.org/drawingml/2006/main" xmlns:p="http://schemas.openxmlformats.org/presentationml/2006/main" xmlns:r="http://schemas.openxmlformats.org/officeDocument/2006/relationships">
+<p:sld xmlns:a="http://schemas.openxmlformats.org/drawingml/2006/main" xmlns:r="http://schemas.openxmlformats.org/officeDocument/2006/relationships" xmlns:p="http://schemas.openxmlformats.org/presentationml/2006/main">
   <p:cSld>
     <p:spTree>
       <p:nvGrpSpPr>
@@ -3098,7 +3122,14 @@
         <p:cNvGrpSpPr/>
         <p:nvPr/>
       </p:nvGrpSpPr>
-      <p:grpSpPr/>
+      <p:grpSpPr>
+        <a:xfrm>
+          <a:off x="0" y="0"/>
+          <a:ext cx="0" cy="0"/>
+          <a:chOff x="0" y="0"/>
+          <a:chExt cx="0" cy="0"/>
+        </a:xfrm>
+      </p:grpSpPr>
       <p:sp>
         <p:nvSpPr>
           <p:cNvPr id="2" name="Rectangle 1"/>
@@ -3139,6 +3170,7 @@
           <a:lstStyle/>
           <a:p>
             <a:pPr algn="ctr"/>
+            <a:endParaRPr/>
           </a:p>
         </p:txBody>
       </p:sp>
@@ -3182,6 +3214,7 @@
           <a:lstStyle/>
           <a:p>
             <a:pPr algn="ctr"/>
+            <a:endParaRPr/>
           </a:p>
         </p:txBody>
       </p:sp>
@@ -3262,7 +3295,7 @@
 </file>
 
 <file path=ppt/slides/slide10.xml><?xml version="1.0" encoding="utf-8"?>
-<p:sld xmlns:a="http://schemas.openxmlformats.org/drawingml/2006/main" xmlns:p="http://schemas.openxmlformats.org/presentationml/2006/main" xmlns:r="http://schemas.openxmlformats.org/officeDocument/2006/relationships">
+<p:sld xmlns:a="http://schemas.openxmlformats.org/drawingml/2006/main" xmlns:r="http://schemas.openxmlformats.org/officeDocument/2006/relationships" xmlns:p="http://schemas.openxmlformats.org/presentationml/2006/main">
   <p:cSld>
     <p:spTree>
       <p:nvGrpSpPr>
@@ -3270,7 +3303,14 @@
         <p:cNvGrpSpPr/>
         <p:nvPr/>
       </p:nvGrpSpPr>
-      <p:grpSpPr/>
+      <p:grpSpPr>
+        <a:xfrm>
+          <a:off x="0" y="0"/>
+          <a:ext cx="0" cy="0"/>
+          <a:chOff x="0" y="0"/>
+          <a:chExt cx="0" cy="0"/>
+        </a:xfrm>
+      </p:grpSpPr>
       <p:sp>
         <p:nvSpPr>
           <p:cNvPr id="2" name="Rectangle 1"/>
@@ -3311,6 +3351,7 @@
           <a:lstStyle/>
           <a:p>
             <a:pPr algn="ctr"/>
+            <a:endParaRPr/>
           </a:p>
         </p:txBody>
       </p:sp>
@@ -3420,6 +3461,7 @@
               </a:defRPr>
             </a:pPr>
             <a:r>
+              <a:rPr dirty="0"/>
               <a:t>•  Core KPIs: Total Applicants (614), Approval Rate (68.7%), Approved (422), Rejected (192), Avg Loan ($146.4K).</a:t>
             </a:r>
           </a:p>
@@ -3436,6 +3478,7 @@
               </a:defRPr>
             </a:pPr>
             <a:r>
+              <a:rPr dirty="0"/>
               <a:t>•  Interactive Filtering: Built global slicers for Gender, Property Area, Education, and Credit History.</a:t>
             </a:r>
           </a:p>
@@ -3452,6 +3495,7 @@
               </a:defRPr>
             </a:pPr>
             <a:r>
+              <a:rPr dirty="0"/>
               <a:t>•  Visual Layout: Combined donut charts, bar plots, and income vs loan scatter visuals.</a:t>
             </a:r>
           </a:p>
@@ -3468,7 +3512,16 @@
               </a:defRPr>
             </a:pPr>
             <a:r>
-              <a:t>•  Executive Dashboard File: Delivered as an interactive Power BI report (Loan Analysis Dashboard.pbix).</a:t>
+              <a:rPr dirty="0"/>
+              <a:t>•  Executive Dashboard File: Delivered as an interactive Power BI report (Loan Analysis </a:t>
+            </a:r>
+            <a:r>
+              <a:rPr dirty="0" err="1"/>
+              <a:t>Dashboard.pbix</a:t>
+            </a:r>
+            <a:r>
+              <a:rPr dirty="0"/>
+              <a:t>).</a:t>
             </a:r>
           </a:p>
         </p:txBody>
@@ -3506,7 +3559,7 @@
 </file>
 
 <file path=ppt/slides/slide11.xml><?xml version="1.0" encoding="utf-8"?>
-<p:sld xmlns:a="http://schemas.openxmlformats.org/drawingml/2006/main" xmlns:p="http://schemas.openxmlformats.org/presentationml/2006/main" xmlns:r="http://schemas.openxmlformats.org/officeDocument/2006/relationships">
+<p:sld xmlns:a="http://schemas.openxmlformats.org/drawingml/2006/main" xmlns:r="http://schemas.openxmlformats.org/officeDocument/2006/relationships" xmlns:p="http://schemas.openxmlformats.org/presentationml/2006/main">
   <p:cSld>
     <p:spTree>
       <p:nvGrpSpPr>
@@ -3514,7 +3567,14 @@
         <p:cNvGrpSpPr/>
         <p:nvPr/>
       </p:nvGrpSpPr>
-      <p:grpSpPr/>
+      <p:grpSpPr>
+        <a:xfrm>
+          <a:off x="0" y="0"/>
+          <a:ext cx="0" cy="0"/>
+          <a:chOff x="0" y="0"/>
+          <a:chExt cx="0" cy="0"/>
+        </a:xfrm>
+      </p:grpSpPr>
       <p:sp>
         <p:nvSpPr>
           <p:cNvPr id="2" name="Rectangle 1"/>
@@ -3555,6 +3615,7 @@
           <a:lstStyle/>
           <a:p>
             <a:pPr algn="ctr"/>
+            <a:endParaRPr/>
           </a:p>
         </p:txBody>
       </p:sp>
@@ -3726,7 +3787,7 @@
 </file>
 
 <file path=ppt/slides/slide12.xml><?xml version="1.0" encoding="utf-8"?>
-<p:sld xmlns:a="http://schemas.openxmlformats.org/drawingml/2006/main" xmlns:p="http://schemas.openxmlformats.org/presentationml/2006/main" xmlns:r="http://schemas.openxmlformats.org/officeDocument/2006/relationships">
+<p:sld xmlns:a="http://schemas.openxmlformats.org/drawingml/2006/main" xmlns:r="http://schemas.openxmlformats.org/officeDocument/2006/relationships" xmlns:p="http://schemas.openxmlformats.org/presentationml/2006/main">
   <p:cSld>
     <p:spTree>
       <p:nvGrpSpPr>
@@ -3734,7 +3795,14 @@
         <p:cNvGrpSpPr/>
         <p:nvPr/>
       </p:nvGrpSpPr>
-      <p:grpSpPr/>
+      <p:grpSpPr>
+        <a:xfrm>
+          <a:off x="0" y="0"/>
+          <a:ext cx="0" cy="0"/>
+          <a:chOff x="0" y="0"/>
+          <a:chExt cx="0" cy="0"/>
+        </a:xfrm>
+      </p:grpSpPr>
       <p:sp>
         <p:nvSpPr>
           <p:cNvPr id="2" name="Rectangle 1"/>
@@ -3775,6 +3843,7 @@
           <a:lstStyle/>
           <a:p>
             <a:pPr algn="ctr"/>
+            <a:endParaRPr/>
           </a:p>
         </p:txBody>
       </p:sp>
@@ -3959,7 +4028,7 @@
 </file>
 
 <file path=ppt/slides/slide2.xml><?xml version="1.0" encoding="utf-8"?>
-<p:sld xmlns:a="http://schemas.openxmlformats.org/drawingml/2006/main" xmlns:p="http://schemas.openxmlformats.org/presentationml/2006/main" xmlns:r="http://schemas.openxmlformats.org/officeDocument/2006/relationships">
+<p:sld xmlns:a="http://schemas.openxmlformats.org/drawingml/2006/main" xmlns:r="http://schemas.openxmlformats.org/officeDocument/2006/relationships" xmlns:p="http://schemas.openxmlformats.org/presentationml/2006/main">
   <p:cSld>
     <p:spTree>
       <p:nvGrpSpPr>
@@ -3967,7 +4036,14 @@
         <p:cNvGrpSpPr/>
         <p:nvPr/>
       </p:nvGrpSpPr>
-      <p:grpSpPr/>
+      <p:grpSpPr>
+        <a:xfrm>
+          <a:off x="0" y="0"/>
+          <a:ext cx="0" cy="0"/>
+          <a:chOff x="0" y="0"/>
+          <a:chExt cx="0" cy="0"/>
+        </a:xfrm>
+      </p:grpSpPr>
       <p:sp>
         <p:nvSpPr>
           <p:cNvPr id="2" name="Rectangle 1"/>
@@ -4008,6 +4084,7 @@
           <a:lstStyle/>
           <a:p>
             <a:pPr algn="ctr"/>
+            <a:endParaRPr/>
           </a:p>
         </p:txBody>
       </p:sp>
@@ -4179,7 +4256,7 @@
 </file>
 
 <file path=ppt/slides/slide3.xml><?xml version="1.0" encoding="utf-8"?>
-<p:sld xmlns:a="http://schemas.openxmlformats.org/drawingml/2006/main" xmlns:p="http://schemas.openxmlformats.org/presentationml/2006/main" xmlns:r="http://schemas.openxmlformats.org/officeDocument/2006/relationships">
+<p:sld xmlns:a="http://schemas.openxmlformats.org/drawingml/2006/main" xmlns:r="http://schemas.openxmlformats.org/officeDocument/2006/relationships" xmlns:p="http://schemas.openxmlformats.org/presentationml/2006/main">
   <p:cSld>
     <p:spTree>
       <p:nvGrpSpPr>
@@ -4187,7 +4264,14 @@
         <p:cNvGrpSpPr/>
         <p:nvPr/>
       </p:nvGrpSpPr>
-      <p:grpSpPr/>
+      <p:grpSpPr>
+        <a:xfrm>
+          <a:off x="0" y="0"/>
+          <a:ext cx="0" cy="0"/>
+          <a:chOff x="0" y="0"/>
+          <a:chExt cx="0" cy="0"/>
+        </a:xfrm>
+      </p:grpSpPr>
       <p:sp>
         <p:nvSpPr>
           <p:cNvPr id="2" name="Rectangle 1"/>
@@ -4228,6 +4312,7 @@
           <a:lstStyle/>
           <a:p>
             <a:pPr algn="ctr"/>
+            <a:endParaRPr/>
           </a:p>
         </p:txBody>
       </p:sp>
@@ -4423,7 +4508,7 @@
 </file>
 
 <file path=ppt/slides/slide4.xml><?xml version="1.0" encoding="utf-8"?>
-<p:sld xmlns:a="http://schemas.openxmlformats.org/drawingml/2006/main" xmlns:p="http://schemas.openxmlformats.org/presentationml/2006/main" xmlns:r="http://schemas.openxmlformats.org/officeDocument/2006/relationships">
+<p:sld xmlns:a="http://schemas.openxmlformats.org/drawingml/2006/main" xmlns:r="http://schemas.openxmlformats.org/officeDocument/2006/relationships" xmlns:p="http://schemas.openxmlformats.org/presentationml/2006/main">
   <p:cSld>
     <p:spTree>
       <p:nvGrpSpPr>
@@ -4431,7 +4516,14 @@
         <p:cNvGrpSpPr/>
         <p:nvPr/>
       </p:nvGrpSpPr>
-      <p:grpSpPr/>
+      <p:grpSpPr>
+        <a:xfrm>
+          <a:off x="0" y="0"/>
+          <a:ext cx="0" cy="0"/>
+          <a:chOff x="0" y="0"/>
+          <a:chExt cx="0" cy="0"/>
+        </a:xfrm>
+      </p:grpSpPr>
       <p:sp>
         <p:nvSpPr>
           <p:cNvPr id="2" name="Rectangle 1"/>
@@ -4472,6 +4564,7 @@
           <a:lstStyle/>
           <a:p>
             <a:pPr algn="ctr"/>
+            <a:endParaRPr/>
           </a:p>
         </p:txBody>
       </p:sp>
@@ -4667,7 +4760,7 @@
 </file>
 
 <file path=ppt/slides/slide5.xml><?xml version="1.0" encoding="utf-8"?>
-<p:sld xmlns:a="http://schemas.openxmlformats.org/drawingml/2006/main" xmlns:p="http://schemas.openxmlformats.org/presentationml/2006/main" xmlns:r="http://schemas.openxmlformats.org/officeDocument/2006/relationships">
+<p:sld xmlns:a="http://schemas.openxmlformats.org/drawingml/2006/main" xmlns:r="http://schemas.openxmlformats.org/officeDocument/2006/relationships" xmlns:p="http://schemas.openxmlformats.org/presentationml/2006/main">
   <p:cSld>
     <p:spTree>
       <p:nvGrpSpPr>
@@ -4675,7 +4768,14 @@
         <p:cNvGrpSpPr/>
         <p:nvPr/>
       </p:nvGrpSpPr>
-      <p:grpSpPr/>
+      <p:grpSpPr>
+        <a:xfrm>
+          <a:off x="0" y="0"/>
+          <a:ext cx="0" cy="0"/>
+          <a:chOff x="0" y="0"/>
+          <a:chExt cx="0" cy="0"/>
+        </a:xfrm>
+      </p:grpSpPr>
       <p:sp>
         <p:nvSpPr>
           <p:cNvPr id="2" name="Rectangle 1"/>
@@ -4716,6 +4816,7 @@
           <a:lstStyle/>
           <a:p>
             <a:pPr algn="ctr"/>
+            <a:endParaRPr/>
           </a:p>
         </p:txBody>
       </p:sp>
@@ -4911,7 +5012,7 @@
 </file>
 
 <file path=ppt/slides/slide6.xml><?xml version="1.0" encoding="utf-8"?>
-<p:sld xmlns:a="http://schemas.openxmlformats.org/drawingml/2006/main" xmlns:p="http://schemas.openxmlformats.org/presentationml/2006/main" xmlns:r="http://schemas.openxmlformats.org/officeDocument/2006/relationships">
+<p:sld xmlns:a="http://schemas.openxmlformats.org/drawingml/2006/main" xmlns:r="http://schemas.openxmlformats.org/officeDocument/2006/relationships" xmlns:p="http://schemas.openxmlformats.org/presentationml/2006/main">
   <p:cSld>
     <p:spTree>
       <p:nvGrpSpPr>
@@ -4919,7 +5020,14 @@
         <p:cNvGrpSpPr/>
         <p:nvPr/>
       </p:nvGrpSpPr>
-      <p:grpSpPr/>
+      <p:grpSpPr>
+        <a:xfrm>
+          <a:off x="0" y="0"/>
+          <a:ext cx="0" cy="0"/>
+          <a:chOff x="0" y="0"/>
+          <a:chExt cx="0" cy="0"/>
+        </a:xfrm>
+      </p:grpSpPr>
       <p:sp>
         <p:nvSpPr>
           <p:cNvPr id="2" name="Rectangle 1"/>
@@ -4960,6 +5068,7 @@
           <a:lstStyle/>
           <a:p>
             <a:pPr algn="ctr"/>
+            <a:endParaRPr/>
           </a:p>
         </p:txBody>
       </p:sp>
@@ -5155,7 +5264,7 @@
 </file>
 
 <file path=ppt/slides/slide7.xml><?xml version="1.0" encoding="utf-8"?>
-<p:sld xmlns:a="http://schemas.openxmlformats.org/drawingml/2006/main" xmlns:p="http://schemas.openxmlformats.org/presentationml/2006/main" xmlns:r="http://schemas.openxmlformats.org/officeDocument/2006/relationships">
+<p:sld xmlns:a="http://schemas.openxmlformats.org/drawingml/2006/main" xmlns:r="http://schemas.openxmlformats.org/officeDocument/2006/relationships" xmlns:p="http://schemas.openxmlformats.org/presentationml/2006/main">
   <p:cSld>
     <p:spTree>
       <p:nvGrpSpPr>
@@ -5163,7 +5272,14 @@
         <p:cNvGrpSpPr/>
         <p:nvPr/>
       </p:nvGrpSpPr>
-      <p:grpSpPr/>
+      <p:grpSpPr>
+        <a:xfrm>
+          <a:off x="0" y="0"/>
+          <a:ext cx="0" cy="0"/>
+          <a:chOff x="0" y="0"/>
+          <a:chExt cx="0" cy="0"/>
+        </a:xfrm>
+      </p:grpSpPr>
       <p:sp>
         <p:nvSpPr>
           <p:cNvPr id="2" name="Rectangle 1"/>
@@ -5204,6 +5320,7 @@
           <a:lstStyle/>
           <a:p>
             <a:pPr algn="ctr"/>
+            <a:endParaRPr/>
           </a:p>
         </p:txBody>
       </p:sp>
@@ -5375,7 +5492,7 @@
 </file>
 
 <file path=ppt/slides/slide8.xml><?xml version="1.0" encoding="utf-8"?>
-<p:sld xmlns:a="http://schemas.openxmlformats.org/drawingml/2006/main" xmlns:p="http://schemas.openxmlformats.org/presentationml/2006/main" xmlns:r="http://schemas.openxmlformats.org/officeDocument/2006/relationships">
+<p:sld xmlns:a="http://schemas.openxmlformats.org/drawingml/2006/main" xmlns:r="http://schemas.openxmlformats.org/officeDocument/2006/relationships" xmlns:p="http://schemas.openxmlformats.org/presentationml/2006/main">
   <p:cSld>
     <p:spTree>
       <p:nvGrpSpPr>
@@ -5383,7 +5500,14 @@
         <p:cNvGrpSpPr/>
         <p:nvPr/>
       </p:nvGrpSpPr>
-      <p:grpSpPr/>
+      <p:grpSpPr>
+        <a:xfrm>
+          <a:off x="0" y="0"/>
+          <a:ext cx="0" cy="0"/>
+          <a:chOff x="0" y="0"/>
+          <a:chExt cx="0" cy="0"/>
+        </a:xfrm>
+      </p:grpSpPr>
       <p:sp>
         <p:nvSpPr>
           <p:cNvPr id="2" name="Rectangle 1"/>
@@ -5424,6 +5548,7 @@
           <a:lstStyle/>
           <a:p>
             <a:pPr algn="ctr"/>
+            <a:endParaRPr/>
           </a:p>
         </p:txBody>
       </p:sp>
@@ -5619,7 +5744,7 @@
 </file>
 
 <file path=ppt/slides/slide9.xml><?xml version="1.0" encoding="utf-8"?>
-<p:sld xmlns:a="http://schemas.openxmlformats.org/drawingml/2006/main" xmlns:p="http://schemas.openxmlformats.org/presentationml/2006/main" xmlns:r="http://schemas.openxmlformats.org/officeDocument/2006/relationships">
+<p:sld xmlns:a="http://schemas.openxmlformats.org/drawingml/2006/main" xmlns:r="http://schemas.openxmlformats.org/officeDocument/2006/relationships" xmlns:p="http://schemas.openxmlformats.org/presentationml/2006/main">
   <p:cSld>
     <p:spTree>
       <p:nvGrpSpPr>
@@ -5627,7 +5752,14 @@
         <p:cNvGrpSpPr/>
         <p:nvPr/>
       </p:nvGrpSpPr>
-      <p:grpSpPr/>
+      <p:grpSpPr>
+        <a:xfrm>
+          <a:off x="0" y="0"/>
+          <a:ext cx="0" cy="0"/>
+          <a:chOff x="0" y="0"/>
+          <a:chExt cx="0" cy="0"/>
+        </a:xfrm>
+      </p:grpSpPr>
       <p:sp>
         <p:nvSpPr>
           <p:cNvPr id="2" name="Rectangle 1"/>
@@ -5668,6 +5800,7 @@
           <a:lstStyle/>
           <a:p>
             <a:pPr algn="ctr"/>
+            <a:endParaRPr/>
           </a:p>
         </p:txBody>
       </p:sp>

</xml_diff>